<commit_message>
Ignore the fetched results directory
publication/results/ is 230 MB pulled from the Zenodo deposit by
publication/data/download_results.sh. The archive is the record; this
directory is a working copy of it and was showing as 526 untracked files.

Also commits the Figure 1 source as edited on 6 August.

Note for whoever regenerates publication/MANIFEST.md: the inventory script
overwrites the whole file and drops the hand-written "Harness layout and
experiment-to-script map" section added in b74ee03. That regeneration was in
the working tree and has been discarded; the script needs to preserve the
section or append below it.

Co-Authored-By: Claude Opus 5 (1M context) <noreply@anthropic.com>
Claude-Session: https://claude.ai/code/session_01VHpHVovmcyNYT2SELM8iy9
</commit_message>
<xml_diff>
--- a/publication/figures/fig1_general_scheme.pptx
+++ b/publication/figures/fig1_general_scheme.pptx
@@ -243,7 +243,7 @@
           <a:p>
             <a:fld id="{15C3AFBB-BB45-1140-BCBD-D63790197BFE}" type="datetimeFigureOut">
               <a:rPr lang="en-US" smtClean="0"/>
-              <a:t>4/8/26</a:t>
+              <a:t>8/6/26</a:t>
             </a:fld>
             <a:endParaRPr lang="en-US"/>
           </a:p>
@@ -413,7 +413,7 @@
           <a:p>
             <a:fld id="{15C3AFBB-BB45-1140-BCBD-D63790197BFE}" type="datetimeFigureOut">
               <a:rPr lang="en-US" smtClean="0"/>
-              <a:t>4/8/26</a:t>
+              <a:t>8/6/26</a:t>
             </a:fld>
             <a:endParaRPr lang="en-US"/>
           </a:p>
@@ -593,7 +593,7 @@
           <a:p>
             <a:fld id="{15C3AFBB-BB45-1140-BCBD-D63790197BFE}" type="datetimeFigureOut">
               <a:rPr lang="en-US" smtClean="0"/>
-              <a:t>4/8/26</a:t>
+              <a:t>8/6/26</a:t>
             </a:fld>
             <a:endParaRPr lang="en-US"/>
           </a:p>
@@ -763,7 +763,7 @@
           <a:p>
             <a:fld id="{15C3AFBB-BB45-1140-BCBD-D63790197BFE}" type="datetimeFigureOut">
               <a:rPr lang="en-US" smtClean="0"/>
-              <a:t>4/8/26</a:t>
+              <a:t>8/6/26</a:t>
             </a:fld>
             <a:endParaRPr lang="en-US"/>
           </a:p>
@@ -1009,7 +1009,7 @@
           <a:p>
             <a:fld id="{15C3AFBB-BB45-1140-BCBD-D63790197BFE}" type="datetimeFigureOut">
               <a:rPr lang="en-US" smtClean="0"/>
-              <a:t>4/8/26</a:t>
+              <a:t>8/6/26</a:t>
             </a:fld>
             <a:endParaRPr lang="en-US"/>
           </a:p>
@@ -1241,7 +1241,7 @@
           <a:p>
             <a:fld id="{15C3AFBB-BB45-1140-BCBD-D63790197BFE}" type="datetimeFigureOut">
               <a:rPr lang="en-US" smtClean="0"/>
-              <a:t>4/8/26</a:t>
+              <a:t>8/6/26</a:t>
             </a:fld>
             <a:endParaRPr lang="en-US"/>
           </a:p>
@@ -1608,7 +1608,7 @@
           <a:p>
             <a:fld id="{15C3AFBB-BB45-1140-BCBD-D63790197BFE}" type="datetimeFigureOut">
               <a:rPr lang="en-US" smtClean="0"/>
-              <a:t>4/8/26</a:t>
+              <a:t>8/6/26</a:t>
             </a:fld>
             <a:endParaRPr lang="en-US"/>
           </a:p>
@@ -1726,7 +1726,7 @@
           <a:p>
             <a:fld id="{15C3AFBB-BB45-1140-BCBD-D63790197BFE}" type="datetimeFigureOut">
               <a:rPr lang="en-US" smtClean="0"/>
-              <a:t>4/8/26</a:t>
+              <a:t>8/6/26</a:t>
             </a:fld>
             <a:endParaRPr lang="en-US"/>
           </a:p>
@@ -1821,7 +1821,7 @@
           <a:p>
             <a:fld id="{15C3AFBB-BB45-1140-BCBD-D63790197BFE}" type="datetimeFigureOut">
               <a:rPr lang="en-US" smtClean="0"/>
-              <a:t>4/8/26</a:t>
+              <a:t>8/6/26</a:t>
             </a:fld>
             <a:endParaRPr lang="en-US"/>
           </a:p>
@@ -2098,7 +2098,7 @@
           <a:p>
             <a:fld id="{15C3AFBB-BB45-1140-BCBD-D63790197BFE}" type="datetimeFigureOut">
               <a:rPr lang="en-US" smtClean="0"/>
-              <a:t>4/8/26</a:t>
+              <a:t>8/6/26</a:t>
             </a:fld>
             <a:endParaRPr lang="en-US"/>
           </a:p>
@@ -2355,7 +2355,7 @@
           <a:p>
             <a:fld id="{15C3AFBB-BB45-1140-BCBD-D63790197BFE}" type="datetimeFigureOut">
               <a:rPr lang="en-US" smtClean="0"/>
-              <a:t>4/8/26</a:t>
+              <a:t>8/6/26</a:t>
             </a:fld>
             <a:endParaRPr lang="en-US"/>
           </a:p>
@@ -2568,7 +2568,7 @@
           <a:p>
             <a:fld id="{15C3AFBB-BB45-1140-BCBD-D63790197BFE}" type="datetimeFigureOut">
               <a:rPr lang="en-US" smtClean="0"/>
-              <a:t>4/8/26</a:t>
+              <a:t>8/6/26</a:t>
             </a:fld>
             <a:endParaRPr lang="en-US"/>
           </a:p>
@@ -6337,8 +6337,8 @@
         </p:nvSpPr>
         <p:spPr>
           <a:xfrm>
-            <a:off x="181244" y="4916502"/>
-            <a:ext cx="6177626" cy="215444"/>
+            <a:off x="106949" y="4922787"/>
+            <a:ext cx="6302053" cy="200055"/>
           </a:xfrm>
           <a:prstGeom prst="rect">
             <a:avLst/>
@@ -6353,16 +6353,16 @@
           <a:p>
             <a:pPr algn="ctr"/>
             <a:r>
-              <a:rPr lang="en-US" sz="800" b="1" dirty="0">
+              <a:rPr lang="en-US" sz="700" b="1" dirty="0">
                 <a:solidFill>
                   <a:srgbClr val="000000"/>
                 </a:solidFill>
                 <a:latin typeface="Arial" panose="020B0604020202020204" pitchFamily="34" charset="0"/>
                 <a:cs typeface="Arial" panose="020B0604020202020204" pitchFamily="34" charset="0"/>
               </a:rPr>
-              <a:t>Total: 36,000+ evaluations across 200 papers, 250 questions, 10 experiments in 2 task domains (QA + code generation)</a:t>
-            </a:r>
-            <a:endParaRPr lang="en-US" sz="800" dirty="0">
+              <a:t>37,451 evaluations across 200 papers, 250 questions, 11 experiments in 2 task domains (QA + code generation) + 8,132 judge-calibration scores</a:t>
+            </a:r>
+            <a:endParaRPr lang="en-US" sz="700" dirty="0">
               <a:latin typeface="Arial" panose="020B0604020202020204" pitchFamily="34" charset="0"/>
               <a:cs typeface="Arial" panose="020B0604020202020204" pitchFamily="34" charset="0"/>
             </a:endParaRPr>
@@ -6951,7 +6951,7 @@
         <p:spPr>
           <a:xfrm>
             <a:off x="5473485" y="3024509"/>
-            <a:ext cx="822333" cy="169277"/>
+            <a:ext cx="822333" cy="246221"/>
           </a:xfrm>
           <a:prstGeom prst="rect">
             <a:avLst/>
@@ -6973,6 +6973,16 @@
               <a:t>122B + 30B models</a:t>
             </a:r>
           </a:p>
+          <a:p>
+            <a:pPr algn="ctr"/>
+            <a:r>
+              <a:rPr lang="en-US" sz="500" dirty="0">
+                <a:latin typeface="Arial" panose="020B0604020202020204" pitchFamily="34" charset="0"/>
+                <a:cs typeface="Arial" panose="020B0604020202020204" pitchFamily="34" charset="0"/>
+              </a:rPr>
+              <a:t>3 strategies</a:t>
+            </a:r>
+          </a:p>
         </p:txBody>
       </p:sp>
       <p:sp>
@@ -7087,8 +7097,8 @@
         </p:nvSpPr>
         <p:spPr>
           <a:xfrm>
-            <a:off x="1829354" y="3303202"/>
-            <a:ext cx="564271" cy="169277"/>
+            <a:off x="1489156" y="3303202"/>
+            <a:ext cx="905534" cy="169277"/>
           </a:xfrm>
           <a:prstGeom prst="rect">
             <a:avLst/>
@@ -7107,7 +7117,7 @@
                 <a:latin typeface="Arial" panose="020B0604020202020204" pitchFamily="34" charset="0"/>
                 <a:cs typeface="Arial" panose="020B0604020202020204" pitchFamily="34" charset="0"/>
               </a:rPr>
-              <a:t>ED Fig 1</a:t>
+              <a:t>ED Fig 1 – Evals:2,336</a:t>
             </a:r>
           </a:p>
         </p:txBody>
@@ -8788,6 +8798,45 @@
                 <a:cs typeface="Arial" panose="020B0604020202020204" pitchFamily="34" charset="0"/>
               </a:rPr>
               <a:t>Executor</a:t>
+            </a:r>
+          </a:p>
+        </p:txBody>
+      </p:sp>
+      <p:sp>
+        <p:nvSpPr>
+          <p:cNvPr id="2" name="TextBox 1">
+            <a:extLst>
+              <a:ext uri="{FF2B5EF4-FFF2-40B4-BE49-F238E27FC236}">
+                <a16:creationId xmlns:a16="http://schemas.microsoft.com/office/drawing/2014/main" id="{C40AB104-2CB6-095B-A10A-17E1E5F98FBB}"/>
+              </a:ext>
+            </a:extLst>
+          </p:cNvPr>
+          <p:cNvSpPr txBox="1"/>
+          <p:nvPr/>
+        </p:nvSpPr>
+        <p:spPr>
+          <a:xfrm>
+            <a:off x="1489156" y="3947947"/>
+            <a:ext cx="905534" cy="169277"/>
+          </a:xfrm>
+          <a:prstGeom prst="rect">
+            <a:avLst/>
+          </a:prstGeom>
+          <a:noFill/>
+        </p:spPr>
+        <p:txBody>
+          <a:bodyPr wrap="square">
+            <a:spAutoFit/>
+          </a:bodyPr>
+          <a:lstStyle/>
+          <a:p>
+            <a:pPr algn="r"/>
+            <a:r>
+              <a:rPr lang="en-US" sz="500" dirty="0">
+                <a:latin typeface="Arial" panose="020B0604020202020204" pitchFamily="34" charset="0"/>
+                <a:cs typeface="Arial" panose="020B0604020202020204" pitchFamily="34" charset="0"/>
+              </a:rPr>
+              <a:t>Evals:408</a:t>
             </a:r>
           </a:p>
         </p:txBody>

</xml_diff>